<commit_message>
Figure S1a/S1b: steeper colors, radius sizing, 10% dot filter
Caption, data-flow deck and sources notes updated; the notebook is gone.

Co-Authored-By: Claude Opus 5.5 <noreply@anthropic.com>
Claude-Session: https://claude.ai/code/session_01EJGU7D6hCyhVnYFFhku6cJ
</commit_message>
<xml_diff>
--- a/data_and_analysis_flow.pptx
+++ b/data_and_analysis_flow.pptx
@@ -114,29 +114,29 @@
   <p:extLst>
     <p:ext uri="{521415D9-36F7-43E2-AB2F-B90AF26B5E84}">
       <p14:sectionLst xmlns:p14="http://schemas.microsoft.com/office/powerpoint/2010/main">
-        <p14:section name="Overview" id="{e62f6b12-109e-3270-b689-47c069e7c7a6}">
+        <p14:section name="Overview" id="{4ad4aecf-e2e3-3e0d-920a-ee69cb2f8e9f}">
           <p14:sldIdLst>
             <p14:sldId id="256"/>
           </p14:sldIdLst>
         </p14:section>
-        <p14:section name="Data" id="{bf5c3d92-1310-0537-b172-f53b1f7212bd}">
+        <p14:section name="Data" id="{1ffa0cfc-dc3f-504a-8295-64975bb30f3b}">
           <p14:sldIdLst>
             <p14:sldId id="257"/>
           </p14:sldIdLst>
         </p14:section>
-        <p14:section name="Figures and tables" id="{1ae5bcbb-ebe0-77e0-7e92-fe39c8ab21be}">
+        <p14:section name="Figures and tables" id="{5e540197-8a04-f29a-238b-6b76b139e9a0}">
           <p14:sldIdLst>
             <p14:sldId id="258"/>
             <p14:sldId id="259"/>
             <p14:sldId id="260"/>
           </p14:sldIdLst>
         </p14:section>
-        <p14:section name="indelsig.net" id="{0cfac75d-4eaf-4d42-5b24-f08be1580911}">
+        <p14:section name="indelsig.net" id="{1fe4ecbd-3a06-9d97-c58e-53a8b8dfad56}">
           <p14:sldIdLst>
             <p14:sldId id="261"/>
           </p14:sldIdLst>
         </p14:section>
-        <p14:section name="New assignments" id="{46f2592b-bd05-ab01-b36a-c46070c54cb4}">
+        <p14:section name="New assignments" id="{079e459d-375d-3b05-794f-a0f21ecfa89d}">
           <p14:sldIdLst>
             <p14:sldId id="262"/>
             <p14:sldId id="263"/>
@@ -7015,7 +7015,7 @@
                   <a:srgbClr val="3B4A54"/>
                 </a:solidFill>
               </a:rPr>
-              <a:t>Figures S2 and S5 are edited by hand from a _draft source. sup_figures_manifest.tsv maps each one to its source.</a:t>
+              <a:t>Figures S2 and S5 are edited by hand from a _draft source. Figure S1 is drawn by its script (2026-10-22). sup_figures_manifest.tsv maps each one to its source.</a:t>
             </a:r>
             <a:endParaRPr lang="en-US" sz="1400" dirty="0"/>
           </a:p>
@@ -7095,7 +7095,7 @@
       </p:sp>
       <p:sp>
         <p:nvSpPr>
-          <p:cNvPr id="6" name="build_fig_s1/Signature Assignment.qmd"/>
+          <p:cNvPr id="6" name="build_fig_s1/make_figure_s1_layout.R"/>
           <p:cNvSpPr txBox="1"/>
           <p:nvPr/>
         </p:nvSpPr>
@@ -7135,7 +7135,7 @@
                 <a:ea typeface="Courier New" pitchFamily="34" charset="-122"/>
                 <a:cs typeface="Courier New" pitchFamily="34" charset="-120"/>
               </a:rPr>
-              <a:t>build_fig_s1/Signature Assignment.qmd</a:t>
+              <a:t>build_fig_s1/make_figure_s1_layout.R</a:t>
             </a:r>
             <a:endParaRPr lang="en-US" sz="1000" dirty="0"/>
           </a:p>
@@ -7182,13 +7182,13 @@
             </a:avLst>
           </a:prstGeom>
           <a:solidFill>
-            <a:srgbClr val="FFFFFF"/>
-          </a:solidFill>
-          <a:ln w="12700">
-            <a:solidFill>
-              <a:srgbClr val="C0392B"/>
-            </a:solidFill>
-            <a:prstDash val="dash"/>
+            <a:srgbClr val="1F5F8B"/>
+          </a:solidFill>
+          <a:ln w="12700">
+            <a:solidFill>
+              <a:srgbClr val="1F5F8B"/>
+            </a:solidFill>
+            <a:prstDash val="solid"/>
           </a:ln>
         </p:spPr>
         <p:txBody>
@@ -7201,7 +7201,7 @@
             <a:r>
               <a:rPr lang="en-US" sz="1100" b="1" dirty="0">
                 <a:solidFill>
-                  <a:srgbClr val="C0392B"/>
+                  <a:srgbClr val="FFFFFF"/>
                 </a:solidFill>
                 <a:latin typeface="Calibri" pitchFamily="34" charset="0"/>
                 <a:ea typeface="Calibri" pitchFamily="34" charset="-122"/>
@@ -7215,43 +7215,7 @@
       </p:sp>
       <p:sp>
         <p:nvSpPr>
-          <p:cNvPr id="9" name="Text 7"/>
-          <p:cNvSpPr txBox="1"/>
-          <p:nvPr/>
-        </p:nvSpPr>
-        <p:spPr>
-          <a:xfrm>
-            <a:off x="10012680" y="1600200"/>
-            <a:ext cx="1737360" cy="274320"/>
-          </a:xfrm>
-          <a:prstGeom prst="rect">
-            <a:avLst/>
-          </a:prstGeom>
-          <a:noFill/>
-          <a:ln/>
-        </p:spPr>
-        <p:txBody>
-          <a:bodyPr wrap="square" lIns="0" tIns="0" rIns="0" bIns="0" rtlCol="0" anchor="ctr"/>
-          <a:lstStyle/>
-          <a:p>
-            <a:pPr indent="0" marL="0">
-              <a:buNone/>
-            </a:pPr>
-            <a:r>
-              <a:rPr lang="en-US" sz="1000" i="1" dirty="0">
-                <a:solidFill>
-                  <a:srgbClr val="C0392B"/>
-                </a:solidFill>
-              </a:rPr>
-              <a:t>colors and dots change</a:t>
-            </a:r>
-            <a:endParaRPr lang="en-US" sz="1000" dirty="0"/>
-          </a:p>
-        </p:txBody>
-      </p:sp>
-      <p:sp>
-        <p:nvSpPr>
-          <p:cNvPr id="10" name="Tables S2, S4, S6 signatures"/>
+          <p:cNvPr id="9" name="Tables S2, S4, S6 signatures"/>
           <p:cNvSpPr txBox="1"/>
           <p:nvPr/>
         </p:nvSpPr>
@@ -7299,7 +7263,7 @@
       </p:sp>
       <p:sp>
         <p:nvSpPr>
-          <p:cNvPr id="11" name="Shape 9"/>
+          <p:cNvPr id="10" name="Shape 8"/>
           <p:cNvSpPr/>
           <p:nvPr/>
         </p:nvSpPr>
@@ -7323,7 +7287,7 @@
       </p:sp>
       <p:sp>
         <p:nvSpPr>
-          <p:cNvPr id="12" name="build_fig_s2/make_figure_s2_layout.R"/>
+          <p:cNvPr id="11" name="build_fig_s2/make_figure_s2_layout.R"/>
           <p:cNvSpPr txBox="1"/>
           <p:nvPr/>
         </p:nvSpPr>
@@ -7371,7 +7335,7 @@
       </p:sp>
       <p:sp>
         <p:nvSpPr>
-          <p:cNvPr id="13" name="Shape 11"/>
+          <p:cNvPr id="12" name="Shape 10"/>
           <p:cNvSpPr/>
           <p:nvPr/>
         </p:nvSpPr>
@@ -7395,7 +7359,7 @@
       </p:sp>
       <p:sp>
         <p:nvSpPr>
-          <p:cNvPr id="14" name="Figure S2"/>
+          <p:cNvPr id="13" name="Figure S2"/>
           <p:cNvSpPr txBox="1"/>
           <p:nvPr/>
         </p:nvSpPr>
@@ -7443,7 +7407,7 @@
       </p:sp>
       <p:sp>
         <p:nvSpPr>
-          <p:cNvPr id="15" name="topography Fisher tests (r.05, r.06)"/>
+          <p:cNvPr id="14" name="topography Fisher tests (r.05, r.06)"/>
           <p:cNvSpPr txBox="1"/>
           <p:nvPr/>
         </p:nvSpPr>
@@ -7491,7 +7455,7 @@
       </p:sp>
       <p:sp>
         <p:nvSpPr>
-          <p:cNvPr id="16" name="Shape 14"/>
+          <p:cNvPr id="15" name="Shape 13"/>
           <p:cNvSpPr/>
           <p:nvPr/>
         </p:nvSpPr>
@@ -7515,7 +7479,7 @@
       </p:sp>
       <p:sp>
         <p:nvSpPr>
-          <p:cNvPr id="17" name="build_fig_s3/r.08_bubbleplot.R"/>
+          <p:cNvPr id="16" name="build_fig_s3/r.08_bubbleplot.R"/>
           <p:cNvSpPr txBox="1"/>
           <p:nvPr/>
         </p:nvSpPr>
@@ -7563,7 +7527,7 @@
       </p:sp>
       <p:sp>
         <p:nvSpPr>
-          <p:cNvPr id="18" name="Shape 16"/>
+          <p:cNvPr id="17" name="Shape 15"/>
           <p:cNvSpPr/>
           <p:nvPr/>
         </p:nvSpPr>
@@ -7587,7 +7551,7 @@
       </p:sp>
       <p:sp>
         <p:nvSpPr>
-          <p:cNvPr id="19" name="Figure S3"/>
+          <p:cNvPr id="18" name="Figure S3"/>
           <p:cNvSpPr txBox="1"/>
           <p:nvPr/>
         </p:nvSpPr>
@@ -7635,7 +7599,7 @@
       </p:sp>
       <p:sp>
         <p:nvSpPr>
-          <p:cNvPr id="20" name="Text 18"/>
+          <p:cNvPr id="19" name="Text 17"/>
           <p:cNvSpPr txBox="1"/>
           <p:nvPr/>
         </p:nvSpPr>
@@ -7671,7 +7635,7 @@
       </p:sp>
       <p:sp>
         <p:nvSpPr>
-          <p:cNvPr id="21" name="replication-timing trends (r.09)"/>
+          <p:cNvPr id="20" name="replication-timing trends (r.09)"/>
           <p:cNvSpPr txBox="1"/>
           <p:nvPr/>
         </p:nvSpPr>
@@ -7719,7 +7683,7 @@
       </p:sp>
       <p:sp>
         <p:nvSpPr>
-          <p:cNvPr id="22" name="Shape 20"/>
+          <p:cNvPr id="21" name="Shape 19"/>
           <p:cNvSpPr/>
           <p:nvPr/>
         </p:nvSpPr>
@@ -7743,7 +7707,7 @@
       </p:sp>
       <p:sp>
         <p:nvSpPr>
-          <p:cNvPr id="23" name="build_fig_s4/r.09_barplot_final.R"/>
+          <p:cNvPr id="22" name="build_fig_s4/r.09_barplot_final.R"/>
           <p:cNvSpPr txBox="1"/>
           <p:nvPr/>
         </p:nvSpPr>
@@ -7791,7 +7755,7 @@
       </p:sp>
       <p:sp>
         <p:nvSpPr>
-          <p:cNvPr id="24" name="Shape 22"/>
+          <p:cNvPr id="23" name="Shape 21"/>
           <p:cNvSpPr/>
           <p:nvPr/>
         </p:nvSpPr>
@@ -7815,7 +7779,7 @@
       </p:sp>
       <p:sp>
         <p:nvSpPr>
-          <p:cNvPr id="25" name="Figure S4"/>
+          <p:cNvPr id="24" name="Figure S4"/>
           <p:cNvSpPr txBox="1"/>
           <p:nvPr/>
         </p:nvSpPr>
@@ -7863,7 +7827,7 @@
       </p:sp>
       <p:sp>
         <p:nvSpPr>
-          <p:cNvPr id="26" name="Text 24"/>
+          <p:cNvPr id="25" name="Text 23"/>
           <p:cNvSpPr txBox="1"/>
           <p:nvPr/>
         </p:nvSpPr>
@@ -7899,7 +7863,7 @@
       </p:sp>
       <p:sp>
         <p:nvSpPr>
-          <p:cNvPr id="27" name="Reijns 2022 spectra"/>
+          <p:cNvPr id="26" name="Reijns 2022 spectra"/>
           <p:cNvSpPr txBox="1"/>
           <p:nvPr/>
         </p:nvSpPr>
@@ -7947,7 +7911,7 @@
       </p:sp>
       <p:sp>
         <p:nvSpPr>
-          <p:cNvPr id="28" name="Shape 26"/>
+          <p:cNvPr id="27" name="Shape 25"/>
           <p:cNvSpPr/>
           <p:nvPr/>
         </p:nvSpPr>
@@ -7971,7 +7935,7 @@
       </p:sp>
       <p:sp>
         <p:nvSpPr>
-          <p:cNvPr id="29" name="build_fig_s5/make_figure_s5_layout.R"/>
+          <p:cNvPr id="28" name="build_fig_s5/make_figure_s5_layout.R"/>
           <p:cNvSpPr txBox="1"/>
           <p:nvPr/>
         </p:nvSpPr>
@@ -8019,7 +7983,7 @@
       </p:sp>
       <p:sp>
         <p:nvSpPr>
-          <p:cNvPr id="30" name="Shape 28"/>
+          <p:cNvPr id="29" name="Shape 27"/>
           <p:cNvSpPr/>
           <p:nvPr/>
         </p:nvSpPr>
@@ -8043,7 +8007,7 @@
       </p:sp>
       <p:sp>
         <p:nvSpPr>
-          <p:cNvPr id="31" name="Figure S5"/>
+          <p:cNvPr id="30" name="Figure S5"/>
           <p:cNvSpPr txBox="1"/>
           <p:nvPr/>
         </p:nvSpPr>
@@ -8091,7 +8055,7 @@
       </p:sp>
       <p:sp>
         <p:nvSpPr>
-          <p:cNvPr id="32" name="assignments, sample_info"/>
+          <p:cNvPr id="31" name="assignments, sample_info"/>
           <p:cNvSpPr txBox="1"/>
           <p:nvPr/>
         </p:nvSpPr>
@@ -8139,7 +8103,7 @@
       </p:sp>
       <p:sp>
         <p:nvSpPr>
-          <p:cNvPr id="33" name="Shape 31"/>
+          <p:cNvPr id="32" name="Shape 30"/>
           <p:cNvSpPr/>
           <p:nvPr/>
         </p:nvSpPr>
@@ -8163,7 +8127,7 @@
       </p:sp>
       <p:sp>
         <p:nvSpPr>
-          <p:cNvPr id="34" name="build_fig_s6/build_fig_s6_stats.R + make"/>
+          <p:cNvPr id="33" name="build_fig_s6/build_fig_s6_stats.R + make"/>
           <p:cNvSpPr txBox="1"/>
           <p:nvPr/>
         </p:nvSpPr>
@@ -8228,7 +8192,7 @@
       </p:sp>
       <p:sp>
         <p:nvSpPr>
-          <p:cNvPr id="35" name="Shape 33"/>
+          <p:cNvPr id="34" name="Shape 32"/>
           <p:cNvSpPr/>
           <p:nvPr/>
         </p:nvSpPr>
@@ -8252,7 +8216,7 @@
       </p:sp>
       <p:sp>
         <p:nvSpPr>
-          <p:cNvPr id="36" name="Figure S6"/>
+          <p:cNvPr id="35" name="Figure S6"/>
           <p:cNvSpPr txBox="1"/>
           <p:nvPr/>
         </p:nvSpPr>
@@ -8300,7 +8264,7 @@
       </p:sp>
       <p:sp>
         <p:nvSpPr>
-          <p:cNvPr id="37" name="Text 35"/>
+          <p:cNvPr id="36" name="Text 34"/>
           <p:cNvSpPr txBox="1"/>
           <p:nvPr/>
         </p:nvSpPr>
@@ -8336,7 +8300,7 @@
       </p:sp>
       <p:sp>
         <p:nvSpPr>
-          <p:cNvPr id="38" name="legend script"/>
+          <p:cNvPr id="37" name="legend script"/>
           <p:cNvSpPr txBox="1"/>
           <p:nvPr/>
         </p:nvSpPr>
@@ -8373,7 +8337,7 @@
       </p:sp>
       <p:sp>
         <p:nvSpPr>
-          <p:cNvPr id="39" name="Text 37"/>
+          <p:cNvPr id="38" name="Text 36"/>
           <p:cNvSpPr txBox="1"/>
           <p:nvPr/>
         </p:nvSpPr>
@@ -8409,7 +8373,7 @@
       </p:sp>
       <p:sp>
         <p:nvSpPr>
-          <p:cNvPr id="40" name="legend data"/>
+          <p:cNvPr id="39" name="legend data"/>
           <p:cNvSpPr txBox="1"/>
           <p:nvPr/>
         </p:nvSpPr>
@@ -8446,7 +8410,7 @@
       </p:sp>
       <p:sp>
         <p:nvSpPr>
-          <p:cNvPr id="41" name="Text 39"/>
+          <p:cNvPr id="40" name="Text 38"/>
           <p:cNvSpPr txBox="1"/>
           <p:nvPr/>
         </p:nvSpPr>
@@ -8482,7 +8446,7 @@
       </p:sp>
       <p:sp>
         <p:nvSpPr>
-          <p:cNvPr id="42" name="legend output"/>
+          <p:cNvPr id="41" name="legend output"/>
           <p:cNvSpPr txBox="1"/>
           <p:nvPr/>
         </p:nvSpPr>
@@ -8519,7 +8483,7 @@
       </p:sp>
       <p:sp>
         <p:nvSpPr>
-          <p:cNvPr id="43" name="Text 41"/>
+          <p:cNvPr id="42" name="Text 40"/>
           <p:cNvSpPr txBox="1"/>
           <p:nvPr/>
         </p:nvSpPr>
@@ -8555,7 +8519,7 @@
       </p:sp>
       <p:sp>
         <p:nvSpPr>
-          <p:cNvPr id="44" name="legend stale"/>
+          <p:cNvPr id="43" name="legend stale"/>
           <p:cNvSpPr txBox="1"/>
           <p:nvPr/>
         </p:nvSpPr>
@@ -8592,7 +8556,7 @@
       </p:sp>
       <p:sp>
         <p:nvSpPr>
-          <p:cNvPr id="45" name="Text 43"/>
+          <p:cNvPr id="44" name="Text 42"/>
           <p:cNvSpPr txBox="1"/>
           <p:nvPr/>
         </p:nvSpPr>
@@ -8628,7 +8592,7 @@
       </p:sp>
       <p:sp>
         <p:nvSpPr>
-          <p:cNvPr id="46" name="legend hand"/>
+          <p:cNvPr id="45" name="legend hand"/>
           <p:cNvSpPr txBox="1"/>
           <p:nvPr/>
         </p:nvSpPr>
@@ -8665,7 +8629,7 @@
       </p:sp>
       <p:sp>
         <p:nvSpPr>
-          <p:cNvPr id="47" name="Text 45"/>
+          <p:cNvPr id="46" name="Text 44"/>
           <p:cNvSpPr txBox="1"/>
           <p:nvPr/>
         </p:nvSpPr>

</xml_diff>